<commit_message>
Comprehensive validation after iteration 5 (30h endTime, 35% ChangeCharging)
</commit_message>
<xml_diff>
--- a/UrbanEV_Results.pptx
+++ b/UrbanEV_Results.pptx
@@ -153,7 +153,7 @@
                 </a:solidFill>
                 <a:latin typeface="Calibri"/>
               </a:rPr>
-              <a:t>Auto-generated after iteration 9 | 130,837 EV Agents | 30 Iterations</a:t>
+              <a:t>Auto-generated after iteration 5 | 130,837 EV Agents | 30 Iterations</a:t>
             </a:r>
           </a:p>
         </p:txBody>
@@ -184,7 +184,7 @@
                 </a:solidFill>
                 <a:latin typeface="Consolas"/>
               </a:rPr>
-              <a:t>Iterations completed: 10</a:t>
+              <a:t>Iterations completed: 6</a:t>
             </a:r>
           </a:p>
           <a:p>
@@ -195,7 +195,7 @@
                 </a:solidFill>
                 <a:latin typeface="Consolas"/>
               </a:rPr>
-              <a:t>Total en-route insertions: 56,179</a:t>
+              <a:t>Total en-route insertions: 30,660</a:t>
             </a:r>
           </a:p>
           <a:p>
@@ -206,7 +206,7 @@
                 </a:solidFill>
                 <a:latin typeface="Consolas"/>
               </a:rPr>
-              <a:t>Home charging sessions: 118,165</a:t>
+              <a:t>Home charging sessions: 40,036</a:t>
             </a:r>
           </a:p>
           <a:p>
@@ -217,7 +217,7 @@
                 </a:solidFill>
                 <a:latin typeface="Consolas"/>
               </a:rPr>
-              <a:t>No-charger-found errors: 86,410</a:t>
+              <a:t>No-charger-found errors: 53,982</a:t>
             </a:r>
           </a:p>
           <a:p>
@@ -228,7 +228,7 @@
                 </a:solidFill>
                 <a:latin typeface="Consolas"/>
               </a:rPr>
-              <a:t>Charger-full retries: 6,086,701</a:t>
+              <a:t>Charger-full retries: 0</a:t>
             </a:r>
           </a:p>
           <a:p>
@@ -395,106 +395,62 @@
                 </a:solidFill>
                 <a:latin typeface="Consolas"/>
               </a:rPr>
-              <a:t>   0         -1.367       -1.367       -1.367       -1.367</a:t>
-            </a:r>
-          </a:p>
-          <a:p>
-            <a:r>
-              <a:rPr lang="en-US" sz="900" dirty="0">
-                <a:solidFill>
-                  <a:srgbClr val="373737"/>
-                </a:solidFill>
-                <a:latin typeface="Consolas"/>
-              </a:rPr>
-              <a:t>   1         -2.658       -3.090       -2.315       -1.541</a:t>
-            </a:r>
-          </a:p>
-          <a:p>
-            <a:r>
-              <a:rPr lang="en-US" sz="900" dirty="0">
-                <a:solidFill>
-                  <a:srgbClr val="373737"/>
-                </a:solidFill>
-                <a:latin typeface="Consolas"/>
-              </a:rPr>
-              <a:t>   2         -4.091       -5.319       -3.470       -1.715</a:t>
-            </a:r>
-          </a:p>
-          <a:p>
-            <a:r>
-              <a:rPr lang="en-US" sz="900" dirty="0">
-                <a:solidFill>
-                  <a:srgbClr val="373737"/>
-                </a:solidFill>
-                <a:latin typeface="Consolas"/>
-              </a:rPr>
-              <a:t>   3         -5.341       -7.455       -4.510       -1.711</a:t>
-            </a:r>
-          </a:p>
-          <a:p>
-            <a:r>
-              <a:rPr lang="en-US" sz="900" dirty="0">
-                <a:solidFill>
-                  <a:srgbClr val="373737"/>
-                </a:solidFill>
-                <a:latin typeface="Consolas"/>
-              </a:rPr>
-              <a:t>   4         -6.230       -9.309       -5.356       -1.598</a:t>
-            </a:r>
-          </a:p>
-          <a:p>
-            <a:r>
-              <a:rPr lang="en-US" sz="900" dirty="0">
-                <a:solidFill>
-                  <a:srgbClr val="373737"/>
-                </a:solidFill>
-                <a:latin typeface="Consolas"/>
-              </a:rPr>
-              <a:t>   5         -6.874      -10.973       -6.075       -1.428</a:t>
-            </a:r>
-          </a:p>
-          <a:p>
-            <a:r>
-              <a:rPr lang="en-US" sz="900" dirty="0">
-                <a:solidFill>
-                  <a:srgbClr val="373737"/>
-                </a:solidFill>
-                <a:latin typeface="Consolas"/>
-              </a:rPr>
-              <a:t>   6         -7.111      -12.022       -6.502       -1.225</a:t>
-            </a:r>
-          </a:p>
-          <a:p>
-            <a:r>
-              <a:rPr lang="en-US" sz="900" dirty="0">
-                <a:solidFill>
-                  <a:srgbClr val="373737"/>
-                </a:solidFill>
-                <a:latin typeface="Consolas"/>
-              </a:rPr>
-              <a:t>   7         -7.202      -12.763       -6.707       -1.040</a:t>
-            </a:r>
-          </a:p>
-          <a:p>
-            <a:r>
-              <a:rPr lang="en-US" sz="900" dirty="0">
-                <a:solidFill>
-                  <a:srgbClr val="373737"/>
-                </a:solidFill>
-                <a:latin typeface="Consolas"/>
-              </a:rPr>
-              <a:t>   8         -7.234      -13.133       -6.707       -0.844</a:t>
-            </a:r>
-          </a:p>
-          <a:p>
-            <a:r>
-              <a:rPr lang="en-US" sz="900" dirty="0">
-                <a:solidFill>
-                  <a:srgbClr val="373737"/>
-                </a:solidFill>
-                <a:latin typeface="Consolas"/>
-              </a:rPr>
-              <a:t>   9         -7.194      -13.189       -6.550       -0.665</a:t>
+              <a:t>   0         -1.258       -1.258       -1.258       -1.258</a:t>
+            </a:r>
+          </a:p>
+          <a:p>
+            <a:r>
+              <a:rPr lang="en-US" sz="900" dirty="0">
+                <a:solidFill>
+                  <a:srgbClr val="373737"/>
+                </a:solidFill>
+                <a:latin typeface="Consolas"/>
+              </a:rPr>
+              <a:t>   1         -2.138       -2.828       -1.942       -1.056</a:t>
+            </a:r>
+          </a:p>
+          <a:p>
+            <a:r>
+              <a:rPr lang="en-US" sz="900" dirty="0">
+                <a:solidFill>
+                  <a:srgbClr val="373737"/>
+                </a:solidFill>
+                <a:latin typeface="Consolas"/>
+              </a:rPr>
+              <a:t>   2         -3.253       -4.795       -2.778       -0.874</a:t>
+            </a:r>
+          </a:p>
+          <a:p>
+            <a:r>
+              <a:rPr lang="en-US" sz="900" dirty="0">
+                <a:solidFill>
+                  <a:srgbClr val="373737"/>
+                </a:solidFill>
+                <a:latin typeface="Consolas"/>
+              </a:rPr>
+              <a:t>   3         -4.272       -6.628       -3.535       -0.661</a:t>
+            </a:r>
+          </a:p>
+          <a:p>
+            <a:r>
+              <a:rPr lang="en-US" sz="900" dirty="0">
+                <a:solidFill>
+                  <a:srgbClr val="373737"/>
+                </a:solidFill>
+                <a:latin typeface="Consolas"/>
+              </a:rPr>
+              <a:t>   4         -4.984       -8.187       -4.149       -0.408</a:t>
+            </a:r>
+          </a:p>
+          <a:p>
+            <a:r>
+              <a:rPr lang="en-US" sz="900" dirty="0">
+                <a:solidFill>
+                  <a:srgbClr val="373737"/>
+                </a:solidFill>
+                <a:latin typeface="Consolas"/>
+              </a:rPr>
+              <a:t>   5         -5.494       -9.539       -4.671       -0.180</a:t>
             </a:r>
           </a:p>
           <a:p>
@@ -516,7 +472,7 @@
                 </a:solidFill>
                 <a:latin typeface="Consolas"/>
               </a:rPr>
-              <a:t>Avg Best trend: -1.367 -&gt; -0.665 (IMPROVING)</a:t>
+              <a:t>Avg Best trend: -1.258 -&gt; -0.180 (IMPROVING)</a:t>
             </a:r>
           </a:p>
         </p:txBody>
@@ -661,106 +617,62 @@
                 </a:solidFill>
                 <a:latin typeface="Consolas"/>
               </a:rPr>
-              <a:t>   0    130,837     76,381      58.4%      76,381     24,717</a:t>
-            </a:r>
-          </a:p>
-          <a:p>
-            <a:r>
-              <a:rPr lang="en-US" sz="900" dirty="0">
-                <a:solidFill>
-                  <a:srgbClr val="373737"/>
-                </a:solidFill>
-                <a:latin typeface="Consolas"/>
-              </a:rPr>
-              <a:t>   1    130,837     54,354      41.5%      54,354     24,717</a:t>
-            </a:r>
-          </a:p>
-          <a:p>
-            <a:r>
-              <a:rPr lang="en-US" sz="900" dirty="0">
-                <a:solidFill>
-                  <a:srgbClr val="373737"/>
-                </a:solidFill>
-                <a:latin typeface="Consolas"/>
-              </a:rPr>
-              <a:t>   2    130,837     48,139      36.8%      48,139     24,717</a:t>
-            </a:r>
-          </a:p>
-          <a:p>
-            <a:r>
-              <a:rPr lang="en-US" sz="900" dirty="0">
-                <a:solidFill>
-                  <a:srgbClr val="373737"/>
-                </a:solidFill>
-                <a:latin typeface="Consolas"/>
-              </a:rPr>
-              <a:t>   3    130,837     44,430      34.0%      44,430     24,717</a:t>
-            </a:r>
-          </a:p>
-          <a:p>
-            <a:r>
-              <a:rPr lang="en-US" sz="900" dirty="0">
-                <a:solidFill>
-                  <a:srgbClr val="373737"/>
-                </a:solidFill>
-                <a:latin typeface="Consolas"/>
-              </a:rPr>
-              <a:t>   4    130,837     41,761      31.9%      41,761     24,717</a:t>
-            </a:r>
-          </a:p>
-          <a:p>
-            <a:r>
-              <a:rPr lang="en-US" sz="900" dirty="0">
-                <a:solidFill>
-                  <a:srgbClr val="373737"/>
-                </a:solidFill>
-                <a:latin typeface="Consolas"/>
-              </a:rPr>
-              <a:t>   5    130,837     39,372      30.1%      39,372     24,717</a:t>
-            </a:r>
-          </a:p>
-          <a:p>
-            <a:r>
-              <a:rPr lang="en-US" sz="900" dirty="0">
-                <a:solidFill>
-                  <a:srgbClr val="373737"/>
-                </a:solidFill>
-                <a:latin typeface="Consolas"/>
-              </a:rPr>
-              <a:t>   6    130,837     37,831      28.9%      37,831     24,717</a:t>
-            </a:r>
-          </a:p>
-          <a:p>
-            <a:r>
-              <a:rPr lang="en-US" sz="900" dirty="0">
-                <a:solidFill>
-                  <a:srgbClr val="373737"/>
-                </a:solidFill>
-                <a:latin typeface="Consolas"/>
-              </a:rPr>
-              <a:t>   7    130,837     36,098      27.6%      36,098     24,717</a:t>
-            </a:r>
-          </a:p>
-          <a:p>
-            <a:r>
-              <a:rPr lang="en-US" sz="900" dirty="0">
-                <a:solidFill>
-                  <a:srgbClr val="373737"/>
-                </a:solidFill>
-                <a:latin typeface="Consolas"/>
-              </a:rPr>
-              <a:t>   8    130,837     34,567      26.4%      34,567     24,717</a:t>
-            </a:r>
-          </a:p>
-          <a:p>
-            <a:r>
-              <a:rPr lang="en-US" sz="900" dirty="0">
-                <a:solidFill>
-                  <a:srgbClr val="373737"/>
-                </a:solidFill>
-                <a:latin typeface="Consolas"/>
-              </a:rPr>
-              <a:t>   9    130,837     33,250      25.4%      33,250     24,717</a:t>
+              <a:t>   0    130,837     76,109      58.2%      76,109     24,717</a:t>
+            </a:r>
+          </a:p>
+          <a:p>
+            <a:r>
+              <a:rPr lang="en-US" sz="900" dirty="0">
+                <a:solidFill>
+                  <a:srgbClr val="373737"/>
+                </a:solidFill>
+                <a:latin typeface="Consolas"/>
+              </a:rPr>
+              <a:t>   1    130,837     53,632      41.0%      53,632     24,717</a:t>
+            </a:r>
+          </a:p>
+          <a:p>
+            <a:r>
+              <a:rPr lang="en-US" sz="900" dirty="0">
+                <a:solidFill>
+                  <a:srgbClr val="373737"/>
+                </a:solidFill>
+                <a:latin typeface="Consolas"/>
+              </a:rPr>
+              <a:t>   2    130,837     48,858      37.3%      48,858     24,717</a:t>
+            </a:r>
+          </a:p>
+          <a:p>
+            <a:r>
+              <a:rPr lang="en-US" sz="900" dirty="0">
+                <a:solidFill>
+                  <a:srgbClr val="373737"/>
+                </a:solidFill>
+                <a:latin typeface="Consolas"/>
+              </a:rPr>
+              <a:t>   3    130,837     45,798      35.0%      45,798     24,717</a:t>
+            </a:r>
+          </a:p>
+          <a:p>
+            <a:r>
+              <a:rPr lang="en-US" sz="900" dirty="0">
+                <a:solidFill>
+                  <a:srgbClr val="373737"/>
+                </a:solidFill>
+                <a:latin typeface="Consolas"/>
+              </a:rPr>
+              <a:t>   4    130,837     43,745      33.4%      43,745     24,717</a:t>
+            </a:r>
+          </a:p>
+          <a:p>
+            <a:r>
+              <a:rPr lang="en-US" sz="900" dirty="0">
+                <a:solidFill>
+                  <a:srgbClr val="373737"/>
+                </a:solidFill>
+                <a:latin typeface="Consolas"/>
+              </a:rPr>
+              <a:t>   5    130,837     42,522      32.5%      42,522     24,717</a:t>
             </a:r>
           </a:p>
           <a:p>
@@ -960,106 +872,62 @@
                 </a:solidFill>
                 <a:latin typeface="Consolas"/>
               </a:rPr>
-              <a:t>   1       24,681</a:t>
-            </a:r>
-          </a:p>
-          <a:p>
-            <a:r>
-              <a:rPr lang="en-US" sz="900" dirty="0">
-                <a:solidFill>
-                  <a:srgbClr val="373737"/>
-                </a:solidFill>
-                <a:latin typeface="Consolas"/>
-              </a:rPr>
-              <a:t>   2       24,720</a:t>
-            </a:r>
-          </a:p>
-          <a:p>
-            <a:r>
-              <a:rPr lang="en-US" sz="900" dirty="0">
-                <a:solidFill>
-                  <a:srgbClr val="373737"/>
-                </a:solidFill>
-                <a:latin typeface="Consolas"/>
-              </a:rPr>
-              <a:t>   3       25,375</a:t>
-            </a:r>
-          </a:p>
-          <a:p>
-            <a:r>
-              <a:rPr lang="en-US" sz="900" dirty="0">
-                <a:solidFill>
-                  <a:srgbClr val="373737"/>
-                </a:solidFill>
-                <a:latin typeface="Consolas"/>
-              </a:rPr>
-              <a:t>   4       26,197</a:t>
-            </a:r>
-          </a:p>
-          <a:p>
-            <a:r>
-              <a:rPr lang="en-US" sz="900" dirty="0">
-                <a:solidFill>
-                  <a:srgbClr val="373737"/>
-                </a:solidFill>
-                <a:latin typeface="Consolas"/>
-              </a:rPr>
-              <a:t>   5       26,425</a:t>
-            </a:r>
-          </a:p>
-          <a:p>
-            <a:r>
-              <a:rPr lang="en-US" sz="900" dirty="0">
-                <a:solidFill>
-                  <a:srgbClr val="373737"/>
-                </a:solidFill>
-                <a:latin typeface="Consolas"/>
-              </a:rPr>
-              <a:t>   6       26,430</a:t>
-            </a:r>
-          </a:p>
-          <a:p>
-            <a:r>
-              <a:rPr lang="en-US" sz="900" dirty="0">
-                <a:solidFill>
-                  <a:srgbClr val="373737"/>
-                </a:solidFill>
-                <a:latin typeface="Consolas"/>
-              </a:rPr>
-              <a:t>   7       26,134</a:t>
-            </a:r>
-          </a:p>
-          <a:p>
-            <a:r>
-              <a:rPr lang="en-US" sz="900" dirty="0">
-                <a:solidFill>
-                  <a:srgbClr val="373737"/>
-                </a:solidFill>
-                <a:latin typeface="Consolas"/>
-              </a:rPr>
-              <a:t>   8       25,807</a:t>
-            </a:r>
-          </a:p>
-          <a:p>
-            <a:r>
-              <a:rPr lang="en-US" sz="900" dirty="0">
-                <a:solidFill>
-                  <a:srgbClr val="373737"/>
-                </a:solidFill>
-                <a:latin typeface="Consolas"/>
-              </a:rPr>
-              <a:t>   9       25,467</a:t>
-            </a:r>
-          </a:p>
-          <a:p>
-            <a:r>
-              <a:rPr lang="en-US" sz="900" dirty="0">
-                <a:solidFill>
-                  <a:srgbClr val="373737"/>
-                </a:solidFill>
-                <a:latin typeface="Consolas"/>
-              </a:rPr>
-              <a:t>  10       25,172</a:t>
+              <a:t>   1       24,438</a:t>
+            </a:r>
+          </a:p>
+          <a:p>
+            <a:r>
+              <a:rPr lang="en-US" sz="900" dirty="0">
+                <a:solidFill>
+                  <a:srgbClr val="373737"/>
+                </a:solidFill>
+                <a:latin typeface="Consolas"/>
+              </a:rPr>
+              <a:t>   2       24,753</a:t>
+            </a:r>
+          </a:p>
+          <a:p>
+            <a:r>
+              <a:rPr lang="en-US" sz="900" dirty="0">
+                <a:solidFill>
+                  <a:srgbClr val="373737"/>
+                </a:solidFill>
+                <a:latin typeface="Consolas"/>
+              </a:rPr>
+              <a:t>   3       24,505</a:t>
+            </a:r>
+          </a:p>
+          <a:p>
+            <a:r>
+              <a:rPr lang="en-US" sz="900" dirty="0">
+                <a:solidFill>
+                  <a:srgbClr val="373737"/>
+                </a:solidFill>
+                <a:latin typeface="Consolas"/>
+              </a:rPr>
+              <a:t>   4       25,066</a:t>
+            </a:r>
+          </a:p>
+          <a:p>
+            <a:r>
+              <a:rPr lang="en-US" sz="900" dirty="0">
+                <a:solidFill>
+                  <a:srgbClr val="373737"/>
+                </a:solidFill>
+                <a:latin typeface="Consolas"/>
+              </a:rPr>
+              <a:t>   5       25,280</a:t>
+            </a:r>
+          </a:p>
+          <a:p>
+            <a:r>
+              <a:rPr lang="en-US" sz="900" dirty="0">
+                <a:solidFill>
+                  <a:srgbClr val="373737"/>
+                </a:solidFill>
+                <a:latin typeface="Consolas"/>
+              </a:rPr>
+              <a:t>   6       25,322</a:t>
             </a:r>
           </a:p>
           <a:p>
@@ -1081,7 +949,7 @@
                 </a:solidFill>
                 <a:latin typeface="Consolas"/>
               </a:rPr>
-              <a:t>Total en-route insertions: 56,179</a:t>
+              <a:t>Total en-route insertions: 30,660</a:t>
             </a:r>
           </a:p>
           <a:p>
@@ -1314,116 +1182,6 @@
                 </a:solidFill>
                 <a:latin typeface="Consolas"/>
               </a:rPr>
-              <a:t>   0            51       0.04%</a:t>
-            </a:r>
-          </a:p>
-          <a:p>
-            <a:r>
-              <a:rPr lang="en-US" sz="900" dirty="0">
-                <a:solidFill>
-                  <a:srgbClr val="373737"/>
-                </a:solidFill>
-                <a:latin typeface="Consolas"/>
-              </a:rPr>
-              <a:t>   1            55       0.04%</a:t>
-            </a:r>
-          </a:p>
-          <a:p>
-            <a:r>
-              <a:rPr lang="en-US" sz="900" dirty="0">
-                <a:solidFill>
-                  <a:srgbClr val="373737"/>
-                </a:solidFill>
-                <a:latin typeface="Consolas"/>
-              </a:rPr>
-              <a:t>   2            57       0.04%</a:t>
-            </a:r>
-          </a:p>
-          <a:p>
-            <a:r>
-              <a:rPr lang="en-US" sz="900" dirty="0">
-                <a:solidFill>
-                  <a:srgbClr val="373737"/>
-                </a:solidFill>
-                <a:latin typeface="Consolas"/>
-              </a:rPr>
-              <a:t>   3            59       0.05%</a:t>
-            </a:r>
-          </a:p>
-          <a:p>
-            <a:r>
-              <a:rPr lang="en-US" sz="900" dirty="0">
-                <a:solidFill>
-                  <a:srgbClr val="373737"/>
-                </a:solidFill>
-                <a:latin typeface="Consolas"/>
-              </a:rPr>
-              <a:t>   4            63       0.05%</a:t>
-            </a:r>
-          </a:p>
-          <a:p>
-            <a:r>
-              <a:rPr lang="en-US" sz="900" dirty="0">
-                <a:solidFill>
-                  <a:srgbClr val="373737"/>
-                </a:solidFill>
-                <a:latin typeface="Consolas"/>
-              </a:rPr>
-              <a:t>   5            62       0.05%</a:t>
-            </a:r>
-          </a:p>
-          <a:p>
-            <a:r>
-              <a:rPr lang="en-US" sz="900" dirty="0">
-                <a:solidFill>
-                  <a:srgbClr val="373737"/>
-                </a:solidFill>
-                <a:latin typeface="Consolas"/>
-              </a:rPr>
-              <a:t>   6            63       0.05%</a:t>
-            </a:r>
-          </a:p>
-          <a:p>
-            <a:r>
-              <a:rPr lang="en-US" sz="900" dirty="0">
-                <a:solidFill>
-                  <a:srgbClr val="373737"/>
-                </a:solidFill>
-                <a:latin typeface="Consolas"/>
-              </a:rPr>
-              <a:t>   7            65       0.05%</a:t>
-            </a:r>
-          </a:p>
-          <a:p>
-            <a:r>
-              <a:rPr lang="en-US" sz="900" dirty="0">
-                <a:solidFill>
-                  <a:srgbClr val="373737"/>
-                </a:solidFill>
-                <a:latin typeface="Consolas"/>
-              </a:rPr>
-              <a:t>   8            68       0.05%</a:t>
-            </a:r>
-          </a:p>
-          <a:p>
-            <a:r>
-              <a:rPr lang="en-US" sz="900" dirty="0">
-                <a:solidFill>
-                  <a:srgbClr val="373737"/>
-                </a:solidFill>
-                <a:latin typeface="Consolas"/>
-              </a:rPr>
-              <a:t>   9            64       0.05%</a:t>
-            </a:r>
-          </a:p>
-          <a:p>
-            <a:r>
-              <a:rPr lang="en-US" sz="900" dirty="0">
-                <a:solidFill>
-                  <a:srgbClr val="373737"/>
-                </a:solidFill>
-                <a:latin typeface="Consolas"/>
-              </a:rPr>
               <a:t/>
             </a:r>
           </a:p>
@@ -1701,18 +1459,18 @@
                 </a:solidFill>
                 <a:latin typeface="Consolas"/>
               </a:rPr>
-              <a:t>  No charger found: 86,410 total across all iterations</a:t>
-            </a:r>
-          </a:p>
-          <a:p>
-            <a:r>
-              <a:rPr lang="en-US" sz="900" dirty="0">
-                <a:solidFill>
-                  <a:srgbClr val="373737"/>
-                </a:solidFill>
-                <a:latin typeface="Consolas"/>
-              </a:rPr>
-              <a:t>  Charger full retries: 6,086,701</a:t>
+              <a:t>  No charger found: 53,982 total across all iterations</a:t>
+            </a:r>
+          </a:p>
+          <a:p>
+            <a:r>
+              <a:rPr lang="en-US" sz="900" dirty="0">
+                <a:solidFill>
+                  <a:srgbClr val="373737"/>
+                </a:solidFill>
+                <a:latin typeface="Consolas"/>
+              </a:rPr>
+              <a:t>  Charger full retries: 0</a:t>
             </a:r>
           </a:p>
           <a:p>
@@ -1817,7 +1575,7 @@
                 </a:solidFill>
                 <a:latin typeface="Calibri"/>
               </a:rPr>
-              <a:t>Summary — After Iteration 9</a:t>
+              <a:t>Summary — After Iteration 5</a:t>
             </a:r>
           </a:p>
         </p:txBody>
@@ -1879,7 +1637,7 @@
                 </a:solidFill>
                 <a:latin typeface="Consolas"/>
               </a:rPr>
-              <a:t>Simulation Progress: 10 of 30 iterations complete</a:t>
+              <a:t>Simulation Progress: 6 of 30 iterations complete</a:t>
             </a:r>
           </a:p>
           <a:p>
@@ -1912,62 +1670,51 @@
                 </a:solidFill>
                 <a:latin typeface="Consolas"/>
               </a:rPr>
-              <a:t>  Avg executed score: -7.194</a:t>
-            </a:r>
-          </a:p>
-          <a:p>
-            <a:r>
-              <a:rPr lang="en-US" sz="900" dirty="0">
-                <a:solidFill>
-                  <a:srgbClr val="373737"/>
-                </a:solidFill>
-                <a:latin typeface="Consolas"/>
-              </a:rPr>
-              <a:t>  Avg best score: -0.665</a:t>
-            </a:r>
-          </a:p>
-          <a:p>
-            <a:r>
-              <a:rPr lang="en-US" sz="900" dirty="0">
-                <a:solidFill>
-                  <a:srgbClr val="373737"/>
-                </a:solidFill>
-                <a:latin typeface="Consolas"/>
-              </a:rPr>
-              <a:t>  Stuck agents: 64 (0.05%)</a:t>
-            </a:r>
-          </a:p>
-          <a:p>
-            <a:r>
-              <a:rPr lang="en-US" sz="900" dirty="0">
-                <a:solidFill>
-                  <a:srgbClr val="373737"/>
-                </a:solidFill>
-                <a:latin typeface="Consolas"/>
-              </a:rPr>
-              <a:t>  SoC problems: 25,172</a:t>
-            </a:r>
-          </a:p>
-          <a:p>
-            <a:r>
-              <a:rPr lang="en-US" sz="900" dirty="0">
-                <a:solidFill>
-                  <a:srgbClr val="373737"/>
-                </a:solidFill>
-                <a:latin typeface="Consolas"/>
-              </a:rPr>
-              <a:t>  En-route insertions: 56,179</a:t>
-            </a:r>
-          </a:p>
-          <a:p>
-            <a:r>
-              <a:rPr lang="en-US" sz="900" dirty="0">
-                <a:solidFill>
-                  <a:srgbClr val="373737"/>
-                </a:solidFill>
-                <a:latin typeface="Consolas"/>
-              </a:rPr>
-              <a:t>  Home sessions: 118,165</a:t>
+              <a:t>  Avg executed score: -5.494</a:t>
+            </a:r>
+          </a:p>
+          <a:p>
+            <a:r>
+              <a:rPr lang="en-US" sz="900" dirty="0">
+                <a:solidFill>
+                  <a:srgbClr val="373737"/>
+                </a:solidFill>
+                <a:latin typeface="Consolas"/>
+              </a:rPr>
+              <a:t>  Avg best score: -0.180</a:t>
+            </a:r>
+          </a:p>
+          <a:p>
+            <a:r>
+              <a:rPr lang="en-US" sz="900" dirty="0">
+                <a:solidFill>
+                  <a:srgbClr val="373737"/>
+                </a:solidFill>
+                <a:latin typeface="Consolas"/>
+              </a:rPr>
+              <a:t>  SoC problems: 25,322</a:t>
+            </a:r>
+          </a:p>
+          <a:p>
+            <a:r>
+              <a:rPr lang="en-US" sz="900" dirty="0">
+                <a:solidFill>
+                  <a:srgbClr val="373737"/>
+                </a:solidFill>
+                <a:latin typeface="Consolas"/>
+              </a:rPr>
+              <a:t>  En-route insertions: 30,660</a:t>
+            </a:r>
+          </a:p>
+          <a:p>
+            <a:r>
+              <a:rPr lang="en-US" sz="900" dirty="0">
+                <a:solidFill>
+                  <a:srgbClr val="373737"/>
+                </a:solidFill>
+                <a:latin typeface="Consolas"/>
+              </a:rPr>
+              <a:t>  Home sessions: 40,036</a:t>
             </a:r>
           </a:p>
           <a:p>

</xml_diff>